<commit_message>
se cambio el curso
</commit_message>
<xml_diff>
--- a/app/templates/universidad_2qrs/plantilla_curso.pptx
+++ b/app/templates/universidad_2qrs/plantilla_curso.pptx
@@ -301,7 +301,7 @@
           <a:p>
             <a:fld id="{03C7FEFC-EB52-44D6-B3F1-2A7BB7FA4226}" type="datetimeFigureOut">
               <a:rPr lang="es-PE" smtClean="0"/>
-              <a:t>7/06/2026</a:t>
+              <a:t>12/06/2026</a:t>
             </a:fld>
             <a:endParaRPr lang="es-PE" dirty="0"/>
           </a:p>
@@ -466,7 +466,7 @@
           <a:p>
             <a:fld id="{64955E78-CBAA-441B-9163-D9CD5E983BDA}" type="datetimeFigureOut">
               <a:rPr lang="en-US" smtClean="0"/>
-              <a:t>6/7/2026</a:t>
+              <a:t>6/12/2026</a:t>
             </a:fld>
             <a:endParaRPr lang="en-US" dirty="0"/>
           </a:p>
@@ -865,7 +865,7 @@
           <a:p>
             <a:fld id="{5C4C4E00-4716-4B48-9D97-535E4F94A274}" type="datetimeFigureOut">
               <a:rPr lang="es-PE" smtClean="0"/>
-              <a:t>7/06/2026</a:t>
+              <a:t>12/06/2026</a:t>
             </a:fld>
             <a:endParaRPr lang="es-PE" dirty="0"/>
           </a:p>
@@ -1035,7 +1035,7 @@
           <a:p>
             <a:fld id="{5C4C4E00-4716-4B48-9D97-535E4F94A274}" type="datetimeFigureOut">
               <a:rPr lang="es-PE" smtClean="0"/>
-              <a:t>7/06/2026</a:t>
+              <a:t>12/06/2026</a:t>
             </a:fld>
             <a:endParaRPr lang="es-PE" dirty="0"/>
           </a:p>
@@ -1215,7 +1215,7 @@
           <a:p>
             <a:fld id="{5C4C4E00-4716-4B48-9D97-535E4F94A274}" type="datetimeFigureOut">
               <a:rPr lang="es-PE" smtClean="0"/>
-              <a:t>7/06/2026</a:t>
+              <a:t>12/06/2026</a:t>
             </a:fld>
             <a:endParaRPr lang="es-PE" dirty="0"/>
           </a:p>
@@ -1385,7 +1385,7 @@
           <a:p>
             <a:fld id="{5C4C4E00-4716-4B48-9D97-535E4F94A274}" type="datetimeFigureOut">
               <a:rPr lang="es-PE" smtClean="0"/>
-              <a:t>7/06/2026</a:t>
+              <a:t>12/06/2026</a:t>
             </a:fld>
             <a:endParaRPr lang="es-PE" dirty="0"/>
           </a:p>
@@ -1629,7 +1629,7 @@
           <a:p>
             <a:fld id="{5C4C4E00-4716-4B48-9D97-535E4F94A274}" type="datetimeFigureOut">
               <a:rPr lang="es-PE" smtClean="0"/>
-              <a:t>7/06/2026</a:t>
+              <a:t>12/06/2026</a:t>
             </a:fld>
             <a:endParaRPr lang="es-PE" dirty="0"/>
           </a:p>
@@ -1861,7 +1861,7 @@
           <a:p>
             <a:fld id="{5C4C4E00-4716-4B48-9D97-535E4F94A274}" type="datetimeFigureOut">
               <a:rPr lang="es-PE" smtClean="0"/>
-              <a:t>7/06/2026</a:t>
+              <a:t>12/06/2026</a:t>
             </a:fld>
             <a:endParaRPr lang="es-PE" dirty="0"/>
           </a:p>
@@ -2228,7 +2228,7 @@
           <a:p>
             <a:fld id="{5C4C4E00-4716-4B48-9D97-535E4F94A274}" type="datetimeFigureOut">
               <a:rPr lang="es-PE" smtClean="0"/>
-              <a:t>7/06/2026</a:t>
+              <a:t>12/06/2026</a:t>
             </a:fld>
             <a:endParaRPr lang="es-PE" dirty="0"/>
           </a:p>
@@ -2346,7 +2346,7 @@
           <a:p>
             <a:fld id="{5C4C4E00-4716-4B48-9D97-535E4F94A274}" type="datetimeFigureOut">
               <a:rPr lang="es-PE" smtClean="0"/>
-              <a:t>7/06/2026</a:t>
+              <a:t>12/06/2026</a:t>
             </a:fld>
             <a:endParaRPr lang="es-PE" dirty="0"/>
           </a:p>
@@ -2441,7 +2441,7 @@
           <a:p>
             <a:fld id="{5C4C4E00-4716-4B48-9D97-535E4F94A274}" type="datetimeFigureOut">
               <a:rPr lang="es-PE" smtClean="0"/>
-              <a:t>7/06/2026</a:t>
+              <a:t>12/06/2026</a:t>
             </a:fld>
             <a:endParaRPr lang="es-PE" dirty="0"/>
           </a:p>
@@ -2718,7 +2718,7 @@
           <a:p>
             <a:fld id="{5C4C4E00-4716-4B48-9D97-535E4F94A274}" type="datetimeFigureOut">
               <a:rPr lang="es-PE" smtClean="0"/>
-              <a:t>7/06/2026</a:t>
+              <a:t>12/06/2026</a:t>
             </a:fld>
             <a:endParaRPr lang="es-PE" dirty="0"/>
           </a:p>
@@ -2975,7 +2975,7 @@
           <a:p>
             <a:fld id="{5C4C4E00-4716-4B48-9D97-535E4F94A274}" type="datetimeFigureOut">
               <a:rPr lang="es-PE" smtClean="0"/>
-              <a:t>7/06/2026</a:t>
+              <a:t>12/06/2026</a:t>
             </a:fld>
             <a:endParaRPr lang="es-PE" dirty="0"/>
           </a:p>
@@ -3188,7 +3188,7 @@
           <a:p>
             <a:fld id="{5C4C4E00-4716-4B48-9D97-535E4F94A274}" type="datetimeFigureOut">
               <a:rPr lang="es-PE" smtClean="0"/>
-              <a:t>7/06/2026</a:t>
+              <a:t>12/06/2026</a:t>
             </a:fld>
             <a:endParaRPr lang="es-PE" dirty="0"/>
           </a:p>
@@ -4494,7 +4494,7 @@
                 <a:ea typeface="Cambria Math" panose="02040503050406030204" pitchFamily="18" charset="0"/>
                 <a:cs typeface="Times New Roman" panose="02020603050405020304" pitchFamily="18" charset="0"/>
               </a:rPr>
-              <a:t>                                                                            {{</a:t>
+              <a:t>                                                                            {{CIUDAD}}, </a:t>
             </a:r>
             <a:r>
               <a:rPr lang="es-PE" sz="1400" dirty="0">
@@ -4505,7 +4505,7 @@
                 <a:ea typeface="Cambria Math" panose="02040503050406030204" pitchFamily="18" charset="0"/>
                 <a:cs typeface="Times New Roman" panose="02020603050405020304" pitchFamily="18" charset="0"/>
               </a:rPr>
-              <a:t>CIUDAD}}, {{FECHA_EMISION_LARGA}}</a:t>
+              <a:t>{{FECHA_EMISION_LARGA}}</a:t>
             </a:r>
             <a:endParaRPr lang="en-US" sz="1400" dirty="0">
               <a:solidFill>

</xml_diff>